<commit_message>
Jour 3 : relecture indépendante intégrée, corrigé stagiaire, procédure Teams à jour
- Corrigé stagiaire du jour 3 (Guide-stagiaire-Jour-3-corriges.pdf) : toutes les réponses
- Guide formateur : création du workflow Teams pas à pas (Send webhook alerts to a channel,
  Copier le lien du webhook), solutions de l'escape game corrigées (canaux, trafic divisé par deux,
  inhibition), réponses manquantes, durées harmonisées
- Guide stagiaire : port 9100 et job="node" dans le prompt, liens par tag, légendes, barème sur 22
- Deck et notes : horaires et durées alignés

Co-Authored-By: Claude Opus 5.5 <noreply@anthropic.com>
Claude-Session: https://claude.ai/code/session_015ZLLamyHhQp1quLQ7Sdqka
</commit_message>
<xml_diff>
--- a/docs/slides/Jour3-Prometheus-Grafana.pptx
+++ b/docs/slides/Jour3-Prometheus-Grafana.pptx
@@ -898,8 +898,8 @@
           <a:p>
             <a:r>
               <a:rPr lang="en-US" dirty="0"/>
-              <a:t>« Dix minutes. Une requête par signal doré, pour toute la boutique, dans Explore. L'IA l'écrit et l'explique, vous la vérifiez, et vous écrivez dans votre guide, avec vos mots, ce qu'elle fait. »
-Je circule. Je fais lire deux explications à voix haute à la fin. Les pièges sont sur la slide : je les montre seulement à la correction.
+              <a:t>« Sept minutes. Une requête par signal doré, pour toute la boutique, dans Explore. L'IA l'écrit et l'explique, vous la vérifiez, et vous écrivez dans votre guide, avec vos mots, ce qu'elle fait. »
+Je circule. Je fais lire deux explications à voix haute à la fin. Les pièges sont sur la slide : je les commente à la correction.
 Valeurs attendues : trafic 6 à 7 req/s ; erreurs 0 ; p95 0,15 à 0,25 s ; CPU quelques %.
 [Repères] 10 minutes. Je circule, je fais lire les explications à voix haute.</a:t>
             </a:r>
@@ -1167,7 +1167,7 @@
           <a:p>
             <a:r>
               <a:rPr lang="en-US" dirty="0"/>
-              <a:t>« Quatre règles, et je les applique dans les deux TP de l'après-midi.
+              <a:t>« Quatre règles, et je les applique dans les deux TP de ce matin.
 Les unités. Jamais un 38491023 brut. bytes devient 36,7 MiB, percentunit devient 73 %, reqps, currencyEUR. Grafana convertit, le code n'a pas à le faire.
 Seuils et couleurs, cohérents sur tout le dashboard. Vert, orange, rouge veulent dire la même chose partout. Visibles sur Stat, Gauge, Table, et même Time series.
 Value mappings : 1 devient UP en vert, 0 devient DOWN en rouge. Un dashboard lisible par quelqu'un qui ne connaît pas Prometheus, un chef de service, le support.
@@ -1261,7 +1261,7 @@
               <a:rPr lang="en-US" dirty="0"/>
               <a:t>« Votre dashboard a trois étages, comme un immeuble. Au rez-de-chaussée, en haut de l'écran, la réponse à "ça va ?" : quatre cases de couleur, une par signal doré. Au premier, les mêmes signaux dans le temps, pour l'équipe technique. Au deuxième, le métier, pour le directeur commercial. Chaque panel a une question en français dans votre guide : vous la posez à l'IA, elle l'explique, vous vérifiez, vous réglez l'affichage. Bloqués plus de cinq minutes sur une requête ? L'annexe de secours, à la fin du guide. Personne ne reste bloqué sur du PromQL aujourd'hui : le sujet, c'est Grafana. »
 Je montre la variable et le premier Stat en direct (cf. guide formateur), puis je les laisse travailler.
-[Repères] 95 minutes en deux temps, autour de la pause. Les requêtes : l'IA, sinon l'annexe de secours.</a:t>
+[Repères] 90 minutes en deux temps, autour de la pause. Les requêtes : l'IA, sinon l'annexe de secours.</a:t>
             </a:r>
             <a:endParaRPr lang="en-US" dirty="0"/>
           </a:p>
@@ -1529,7 +1529,7 @@
             <a:r>
               <a:rPr lang="en-US" dirty="0"/>
               <a:t>« Vous êtes des gens d'infrastructure. Lundi, ce n'est pas vous qui instrumenterez les applications : ce sont vos développeurs. Et PromQL, je vous l'ai dit, une IA l'écrit très bien. Mais une IA se trompe avec beaucoup d'assurance. Donc la compétence d'aujourd'hui, ce n'est pas d'écrire du PromQL : c'est de le demander, de le comprendre, et de le vérifier. Je vous demanderai à chaque fois de faire expliquer la requête par l'IA : l'objectif, c'est que vous sachiez ce que fait chaque ligne. »
-Je laisse la phrase affichée trois secondes de silence. Elle donne le ton de la journée.</a:t>
+Je laisse la phrase affichée, avec trois secondes de silence. Elle donne le ton de la journée.</a:t>
             </a:r>
             <a:endParaRPr lang="en-US" dirty="0"/>
           </a:p>
@@ -2423,7 +2423,7 @@
           <a:p>
             <a:r>
               <a:rPr lang="en-US" dirty="0"/>
-              <a:t>« Point important pour vous, puisque vous utilisez Teams. Pendant des années, on créait un "connecteur Incoming Webhook" dans un canal. Microsoft l'a remplacé par les workflows. Dans Teams : le canal, les trois points, Workflows, et le modèle "Send webhook alerts to a channel", qui s'appelle aussi "Post to a channel when a webhook request is received". Vous nommez le workflow, vous choisissez l'équipe et le canal, et Teams vous donne une adresse. »
+              <a:t>« Point important pour vous, puisque vous utilisez Teams. Pendant des années, on créait un "connecteur Incoming Webhook" dans un canal. Microsoft l'a remplacé par les workflows. Dans Teams : le canal, les trois points, Workflows, et le modèle "Send webhook alerts to a channel", qui s'appelle aussi "Post to a channel when a webhook request is received". Vous vérifiez l'équipe et le canal, Enregistrer, puis "Copier le lien du webhook" : c'est l'adresse. »
 « Cette adresse est un secret : quiconque l'a peut écrire dans votre canal. Donc dans Grafana, on la colle dans un contact point Microsoft Teams. Dans l'Alertmanager, on la met dans un fichier à part, webhook_url_file, qui ne part pas dans Git. Au lab, la commande ./jour3.sh teams fait exactement ça. »
 Si la politique de l'entreprise bloque les workflows : un webhook vers un service intermédiaire, ou l'e-mail vers l'adresse du canal Teams (chaque canal a une adresse e-mail).</a:t>
             </a:r>
@@ -2695,7 +2695,7 @@
               <a:rPr lang="en-US" dirty="0"/>
               <a:t>« Le directeur commercial ne lira jamais un fichier YAML, et il veut pouvoir changer son seuil lui-même. On lui fait son alerte dans Grafana. Et on ne refait pas les alertes techniques du TP C. »
 « Le moment que j'attends depuis ce matin : chacun crée un contact point Microsoft Teams avec l'adresse du canal de la salle, et clique sur Test. Regardez l'écran. » Les messages arrivent les uns après les autres dans le Teams projeté. Effet garanti.
-La règle métier se déclenche avec ./lab.sh traffic 1 : le chiffre d'affaires tombe d'environ 170 000 à 20 000 € par heure en deux minutes.
+La règle métier se déclenche avec ./lab.sh traffic 1 : le chiffre d'affaires tombe d'environ 180 000 € par heure à moins de 40 000 en deux à trois minutes.
 [Repères] 30 minutes. Le moment où les messages des stagiaires arrivent dans le Teams projeté.</a:t>
             </a:r>
             <a:endParaRPr lang="en-US" dirty="0"/>
@@ -3051,9 +3051,9 @@
           <a:p>
             <a:r>
               <a:rPr lang="en-US" dirty="0"/>
-              <a:t>« Six règles de configuration, que vous allez chercher dans un fichier réel dans dix minutes.
+              <a:t>« Six règles de configuration. Vous les retrouverez en checklist à la fin de votre guide, à cocher avant chaque mise en production.
 Des intervalles sages : 15 secondes, c'est le standard. 1 seconde, c'est 15 fois plus d'échantillons, 15 fois plus de disque, et vous ne verrez rien de plus. Et le timeout toujours plus petit que l'intervalle, sinon Prometheus refuse de démarrer.
-Des labels qui identifient : cluster et replica en external_labels, c'est ce qui a permis à Thanos de dédupliquer. env, team, service sur les cibles : c'est ce qui permet de router les alertes. Et jamais un identifiant unique en label : un user_id, c'est une série par client, un million de clients, un million de séries, Prometheus tombe.
+Des labels qui identifient : cluster et replica en external_labels, c'est ce qui permettra à Thanos de dédupliquer, tout à l'heure. env, team, service sur les cibles : c'est ce qui permet de router les alertes. Et jamais un identifiant unique en label : un user_id, c'est une série par client, un million de clients, un million de séries, Prometheus tombe.
 Des garde-fous : sample_limit sur un exporter que vous ne maîtrisez pas. S'il se met à exposer 200 000 séries, le scrape est refusé et up passe à 0 : vous le voyez, Prometheus survit.
 Valider : promtool, en CI. Mais promtool vérifie la syntaxe, pas le bon sens.
 La rétention : 15 à 30 jours en local. Au-delà, c'est le travail de Thanos.
@@ -6110,7 +6110,7 @@
                 <a:ea typeface="Calibri" pitchFamily="34" charset="-122"/>
                 <a:cs typeface="Calibri" pitchFamily="34" charset="-120"/>
               </a:rPr>
-              <a:t>Une requête par signal doré, pour toute la boutique, demandée à l'IA, expliquée, vérifiée. Dans Explore : $__rate_interval devient 5m, et pas de filtre instance.</a:t>
+              <a:t>Une requête par signal doré, pour toute la boutique, demandée à l'IA, expliquée, vérifiée. Dans Explore : $__rate_interval devient 5m, et pas de filtre instance. 7 minutes.</a:t>
             </a:r>
             <a:endParaRPr lang="en-US" sz="1500" dirty="0"/>
           </a:p>
@@ -10283,7 +10283,7 @@
                 <a:ea typeface="Calibri" pitchFamily="34" charset="-122"/>
                 <a:cs typeface="Calibri" pitchFamily="34" charset="-120"/>
               </a:rPr>
-              <a:t>Panel Text, annotations Chaos, lien vers le TP B, crash test.</a:t>
+              <a:t>Panel Text, annotations Chaos, tag et liens, crash test.</a:t>
             </a:r>
             <a:endParaRPr lang="en-US" sz="1050" dirty="0"/>
           </a:p>
@@ -19100,7 +19100,7 @@
                           <a:ea typeface="Calibri" pitchFamily="34" charset="-122"/>
                           <a:cs typeface="Calibri" pitchFamily="34" charset="-120"/>
                         </a:rPr>
-                        <a:t>Auto-audit, bonnes pratiques</a:t>
+                        <a:t>Auto-audit des tableaux de bord</a:t>
                       </a:r>
                       <a:endParaRPr lang="en-US" sz="1200" dirty="0">
                         <a:latin typeface="Calibri" charset="0"/>
@@ -19232,7 +19232,7 @@
                           <a:ea typeface="Calibri" pitchFamily="34" charset="-122"/>
                           <a:cs typeface="Calibri" pitchFamily="34" charset="-120"/>
                         </a:rPr>
-                        <a:t>13h30</a:t>
+                        <a:t>13h40</a:t>
                       </a:r>
                       <a:endParaRPr lang="en-US" sz="1200" dirty="0">
                         <a:latin typeface="Calibri" charset="0"/>
@@ -19691,7 +19691,7 @@
                           <a:ea typeface="Calibri" pitchFamily="34" charset="-122"/>
                           <a:cs typeface="Calibri" pitchFamily="34" charset="-120"/>
                         </a:rPr>
-                        <a:t>Escape game : la boutique sabotée</a:t>
+                        <a:t>Bonnes pratiques, escape game</a:t>
                       </a:r>
                       <a:endParaRPr lang="en-US" sz="1200" dirty="0">
                         <a:latin typeface="Calibri" charset="0"/>

</xml_diff>